<commit_message>
review comments in presentation updated before the review
</commit_message>
<xml_diff>
--- a/Presentation/Observability_Strategy_Presentation-v0.2.pptx
+++ b/Presentation/Observability_Strategy_Presentation-v0.2.pptx
@@ -5293,15 +5293,21 @@
           <a:lstStyle/>
           <a:p>
             <a:pPr algn="r"/>
-            <a:r>
+            <a:fld id="{11111111-1111-1111-1111-111111111111}" type="slidenum">
               <a:rPr sz="1000" b="0">
                 <a:solidFill>
                   <a:srgbClr val="555555"/>
                 </a:solidFill>
                 <a:latin typeface="Segoe UI"/>
               </a:rPr>
-              <a:t>12 / 12</a:t>
-            </a:r>
+              <a:t>10</a:t>
+            </a:fld>
+            <a:endParaRPr sz="1000" b="0">
+              <a:solidFill>
+                <a:srgbClr val="555555"/>
+              </a:solidFill>
+              <a:latin typeface="Segoe UI"/>
+            </a:endParaRPr>
           </a:p>
         </p:txBody>
       </p:sp>
@@ -6446,15 +6452,21 @@
           <a:lstStyle/>
           <a:p>
             <a:pPr algn="r"/>
-            <a:r>
+            <a:fld id="{11111111-1111-1111-1111-111111111111}" type="slidenum">
               <a:rPr sz="1000" b="0">
                 <a:solidFill>
                   <a:srgbClr val="555555"/>
                 </a:solidFill>
                 <a:latin typeface="Segoe UI"/>
               </a:rPr>
-              <a:t>4 / 12</a:t>
-            </a:r>
+              <a:t>11</a:t>
+            </a:fld>
+            <a:endParaRPr sz="1000" b="0">
+              <a:solidFill>
+                <a:srgbClr val="555555"/>
+              </a:solidFill>
+              <a:latin typeface="Segoe UI"/>
+            </a:endParaRPr>
           </a:p>
         </p:txBody>
       </p:sp>
@@ -7155,15 +7167,21 @@
           <a:lstStyle/>
           <a:p>
             <a:pPr algn="r"/>
-            <a:r>
+            <a:fld id="{11111111-1111-1111-1111-111111111111}" type="slidenum">
               <a:rPr sz="1000" b="0">
                 <a:solidFill>
                   <a:srgbClr val="555555"/>
                 </a:solidFill>
                 <a:latin typeface="Segoe UI"/>
               </a:rPr>
-              <a:t>6 / 12</a:t>
-            </a:r>
+              <a:t>12</a:t>
+            </a:fld>
+            <a:endParaRPr sz="1000" b="0">
+              <a:solidFill>
+                <a:srgbClr val="555555"/>
+              </a:solidFill>
+              <a:latin typeface="Segoe UI"/>
+            </a:endParaRPr>
           </a:p>
         </p:txBody>
       </p:sp>
@@ -7783,15 +7801,21 @@
           <a:lstStyle/>
           <a:p>
             <a:pPr algn="r"/>
-            <a:r>
+            <a:fld id="{11111111-1111-1111-1111-111111111111}" type="slidenum">
               <a:rPr sz="1000" b="0">
                 <a:solidFill>
                   <a:srgbClr val="555555"/>
                 </a:solidFill>
                 <a:latin typeface="Segoe UI"/>
               </a:rPr>
-              <a:t>2 / 12</a:t>
-            </a:r>
+              <a:t>2</a:t>
+            </a:fld>
+            <a:endParaRPr sz="1000" b="0">
+              <a:solidFill>
+                <a:srgbClr val="555555"/>
+              </a:solidFill>
+              <a:latin typeface="Segoe UI"/>
+            </a:endParaRPr>
           </a:p>
         </p:txBody>
       </p:sp>
@@ -8588,15 +8612,21 @@
           <a:lstStyle/>
           <a:p>
             <a:pPr algn="r"/>
-            <a:r>
+            <a:fld id="{11111111-1111-1111-1111-111111111111}" type="slidenum">
               <a:rPr sz="1000" b="0">
                 <a:solidFill>
                   <a:srgbClr val="555555"/>
                 </a:solidFill>
                 <a:latin typeface="Segoe UI"/>
               </a:rPr>
-              <a:t>3 / 12</a:t>
-            </a:r>
+              <a:t>3</a:t>
+            </a:fld>
+            <a:endParaRPr sz="1000" b="0">
+              <a:solidFill>
+                <a:srgbClr val="555555"/>
+              </a:solidFill>
+              <a:latin typeface="Segoe UI"/>
+            </a:endParaRPr>
           </a:p>
         </p:txBody>
       </p:sp>
@@ -9059,15 +9089,21 @@
           <a:lstStyle/>
           <a:p>
             <a:pPr algn="r"/>
-            <a:r>
+            <a:fld id="{11111111-1111-1111-1111-111111111111}" type="slidenum">
               <a:rPr sz="1000" b="0">
                 <a:solidFill>
                   <a:srgbClr val="555555"/>
                 </a:solidFill>
                 <a:latin typeface="Segoe UI"/>
               </a:rPr>
-              <a:t>5 / 12</a:t>
-            </a:r>
+              <a:t>4</a:t>
+            </a:fld>
+            <a:endParaRPr sz="1000" b="0">
+              <a:solidFill>
+                <a:srgbClr val="555555"/>
+              </a:solidFill>
+              <a:latin typeface="Segoe UI"/>
+            </a:endParaRPr>
           </a:p>
         </p:txBody>
       </p:sp>
@@ -9303,7 +9339,7 @@
                 </a:solidFill>
                 <a:latin typeface="Segoe UI"/>
               </a:rPr>
-              <a:t> — a small dedicated Platform and Site Reliability squad, augmented by a Community of Practice that draws on existing engineers; no large net-new headcount.</a:t>
+              <a:t> — we already have engineers building application logging and a separate team beginning infrastructure observability; the strategy brings these efforts together into one holistic, cross-domain practice rather than adding net-new headcount.</a:t>
             </a:r>
           </a:p>
           <a:p>
@@ -9393,7 +9429,7 @@
                 </a:solidFill>
                 <a:latin typeface="Segoe UI"/>
               </a:rPr>
-              <a:t> — formal FinOps practice with budget envelopes per service tier and automated alerts on variance.</a:t>
+              <a:t> — no FinOps capability exists today; we must define and standardise one as a priority, establishing budget envelopes per service tier and automated variance alerts to control observability and cloud spend.</a:t>
             </a:r>
           </a:p>
           <a:p>
@@ -9423,7 +9459,7 @@
                 </a:solidFill>
                 <a:latin typeface="Segoe UI"/>
               </a:rPr>
-              <a:t> — engineers across the organisation up-skilled through a champions network, not a parallel team.</a:t>
+              <a:t> — engineers across the organisation up-skilled through a Community of Practice and champions network, accelerating the unified observability practice without a parallel team.</a:t>
             </a:r>
           </a:p>
         </p:txBody>
@@ -9530,15 +9566,21 @@
           <a:lstStyle/>
           <a:p>
             <a:pPr algn="r"/>
-            <a:r>
+            <a:fld id="{11111111-1111-1111-1111-111111111111}" type="slidenum">
               <a:rPr sz="1000" b="0">
                 <a:solidFill>
                   <a:srgbClr val="555555"/>
                 </a:solidFill>
                 <a:latin typeface="Segoe UI"/>
               </a:rPr>
-              <a:t>7 / 12</a:t>
-            </a:r>
+              <a:t>5</a:t>
+            </a:fld>
+            <a:endParaRPr sz="1000" b="0">
+              <a:solidFill>
+                <a:srgbClr val="555555"/>
+              </a:solidFill>
+              <a:latin typeface="Segoe UI"/>
+            </a:endParaRPr>
           </a:p>
         </p:txBody>
       </p:sp>
@@ -10308,98 +10350,21 @@
           <a:lstStyle/>
           <a:p>
             <a:pPr algn="r"/>
-            <a:r>
+            <a:fld id="{11111111-1111-1111-1111-111111111111}" type="slidenum">
               <a:rPr sz="1000" b="0">
                 <a:solidFill>
                   <a:srgbClr val="555555"/>
                 </a:solidFill>
                 <a:latin typeface="Segoe UI"/>
               </a:rPr>
-              <a:t>8 / 12</a:t>
-            </a:r>
-          </a:p>
-        </p:txBody>
-      </p:sp>
-      <p:sp>
-        <p:nvSpPr>
-          <p:cNvPr id="13" name="Rectangle 12">
-            <a:extLst>
-              <a:ext uri="{FF2B5EF4-FFF2-40B4-BE49-F238E27FC236}">
-                <a16:creationId xmlns:a16="http://schemas.microsoft.com/office/drawing/2014/main" id="{C4AFEBFB-C563-74E1-1C63-E105A6BA376F}"/>
-              </a:ext>
-            </a:extLst>
-          </p:cNvPr>
-          <p:cNvSpPr/>
-          <p:nvPr/>
-        </p:nvSpPr>
-        <p:spPr>
-          <a:xfrm>
-            <a:off x="1665515" y="-322549"/>
-            <a:ext cx="9013372" cy="2003842"/>
-          </a:xfrm>
-          <a:prstGeom prst="rect">
-            <a:avLst/>
-          </a:prstGeom>
-        </p:spPr>
-        <p:style>
-          <a:lnRef idx="2">
-            <a:schemeClr val="accent3">
-              <a:shade val="15000"/>
-            </a:schemeClr>
-          </a:lnRef>
-          <a:fillRef idx="1">
-            <a:schemeClr val="accent3"/>
-          </a:fillRef>
-          <a:effectRef idx="0">
-            <a:schemeClr val="accent3"/>
-          </a:effectRef>
-          <a:fontRef idx="minor">
-            <a:schemeClr val="lt1"/>
-          </a:fontRef>
-        </p:style>
-        <p:txBody>
-          <a:bodyPr rtlCol="0" anchor="ctr"/>
-          <a:lstStyle/>
-          <a:p>
-            <a:pPr algn="ctr"/>
-            <a:r>
-              <a:rPr lang="en-US" dirty="0">
-                <a:solidFill>
-                  <a:schemeClr val="lt1"/>
-                </a:solidFill>
-              </a:rPr>
-              <a:t>Keep But change/ add.</a:t>
-            </a:r>
-          </a:p>
-          <a:p>
-            <a:pPr algn="ctr"/>
-            <a:endParaRPr lang="en-US" dirty="0"/>
-          </a:p>
-          <a:p>
-            <a:pPr algn="ctr"/>
-            <a:r>
-              <a:rPr lang="en-US" dirty="0">
-                <a:solidFill>
-                  <a:schemeClr val="lt1"/>
-                </a:solidFill>
-              </a:rPr>
-              <a:t>Refocus this page to bring in the point that as part of Ian core, etc. there’s already an effort to do observability in a proper method. We are bringing strategy and consistent approach to that method, as well as joining out the infrastructure, logging and monitoring with the application.</a:t>
-            </a:r>
-            <a:br>
-              <a:rPr lang="en-US" dirty="0">
-                <a:solidFill>
-                  <a:schemeClr val="lt1"/>
-                </a:solidFill>
-              </a:rPr>
-            </a:br>
-            <a:r>
-              <a:rPr lang="en-US" dirty="0">
-                <a:solidFill>
-                  <a:schemeClr val="lt1"/>
-                </a:solidFill>
-              </a:rPr>
-              <a:t>We should also note that there is a quality team, and that should bring SRE as part of this which will be relying upon due to observability.</a:t>
-            </a:r>
+              <a:t>6</a:t>
+            </a:fld>
+            <a:endParaRPr sz="1000" b="0">
+              <a:solidFill>
+                <a:srgbClr val="555555"/>
+              </a:solidFill>
+              <a:latin typeface="Segoe UI"/>
+            </a:endParaRPr>
           </a:p>
         </p:txBody>
       </p:sp>
@@ -10531,7 +10496,7 @@
           <a:p>
             <a:pPr algn="l"/>
             <a:r>
-              <a:rPr sz="3200" b="1">
+              <a:rPr sz="3200" b="1" dirty="0">
                 <a:solidFill>
                   <a:srgbClr val="0B3D91"/>
                 </a:solidFill>
@@ -10871,94 +10836,21 @@
           <a:lstStyle/>
           <a:p>
             <a:pPr algn="r"/>
-            <a:r>
+            <a:fld id="{11111111-1111-1111-1111-111111111111}" type="slidenum">
               <a:rPr sz="1000" b="0">
                 <a:solidFill>
                   <a:srgbClr val="555555"/>
                 </a:solidFill>
                 <a:latin typeface="Segoe UI"/>
               </a:rPr>
-              <a:t>9 / 12</a:t>
-            </a:r>
-          </a:p>
-        </p:txBody>
-      </p:sp>
-      <p:sp>
-        <p:nvSpPr>
-          <p:cNvPr id="10" name="Rectangle 9">
-            <a:extLst>
-              <a:ext uri="{FF2B5EF4-FFF2-40B4-BE49-F238E27FC236}">
-                <a16:creationId xmlns:a16="http://schemas.microsoft.com/office/drawing/2014/main" id="{7E9FC3E1-006C-DC59-4929-87B0EFF5A8B6}"/>
-              </a:ext>
-            </a:extLst>
-          </p:cNvPr>
-          <p:cNvSpPr/>
-          <p:nvPr/>
-        </p:nvSpPr>
-        <p:spPr>
-          <a:xfrm>
-            <a:off x="1665515" y="-322549"/>
-            <a:ext cx="9013372" cy="2003842"/>
-          </a:xfrm>
-          <a:prstGeom prst="rect">
-            <a:avLst/>
-          </a:prstGeom>
-        </p:spPr>
-        <p:style>
-          <a:lnRef idx="2">
-            <a:schemeClr val="accent3">
-              <a:shade val="15000"/>
-            </a:schemeClr>
-          </a:lnRef>
-          <a:fillRef idx="1">
-            <a:schemeClr val="accent3"/>
-          </a:fillRef>
-          <a:effectRef idx="0">
-            <a:schemeClr val="accent3"/>
-          </a:effectRef>
-          <a:fontRef idx="minor">
-            <a:schemeClr val="lt1"/>
-          </a:fontRef>
-        </p:style>
-        <p:txBody>
-          <a:bodyPr rtlCol="0" anchor="ctr"/>
-          <a:lstStyle/>
-          <a:p>
-            <a:pPr algn="ctr"/>
-            <a:r>
-              <a:rPr lang="en-US" dirty="0">
-                <a:solidFill>
-                  <a:schemeClr val="lt1"/>
-                </a:solidFill>
-              </a:rPr>
-              <a:t>Keep But change/ add.</a:t>
-            </a:r>
-            <a:br>
-              <a:rPr lang="en-US" dirty="0">
-                <a:solidFill>
-                  <a:schemeClr val="lt1"/>
-                </a:solidFill>
-              </a:rPr>
-            </a:br>
-            <a:br>
-              <a:rPr lang="en-US" dirty="0">
-                <a:solidFill>
-                  <a:schemeClr val="lt1"/>
-                </a:solidFill>
-              </a:rPr>
-            </a:br>
-            <a:r>
-              <a:rPr lang="en-US" dirty="0">
-                <a:solidFill>
-                  <a:schemeClr val="lt1"/>
-                </a:solidFill>
-              </a:rPr>
-              <a:t>We don’t need regurgitation of government from an architecture standpoint what we should highlight here is COE have responsibility for setting standards and the product group of responsibilities for implementing the standards availability and many other aspects of engineering.</a:t>
-            </a:r>
-          </a:p>
-          <a:p>
-            <a:pPr algn="ctr"/>
-            <a:endParaRPr lang="en-US" dirty="0"/>
+              <a:t>7</a:t>
+            </a:fld>
+            <a:endParaRPr sz="1000" b="0">
+              <a:solidFill>
+                <a:srgbClr val="555555"/>
+              </a:solidFill>
+              <a:latin typeface="Segoe UI"/>
+            </a:endParaRPr>
           </a:p>
         </p:txBody>
       </p:sp>
@@ -11500,15 +11392,21 @@
           <a:lstStyle/>
           <a:p>
             <a:pPr algn="r"/>
-            <a:r>
+            <a:fld id="{11111111-1111-1111-1111-111111111111}" type="slidenum">
               <a:rPr sz="1000" b="0">
                 <a:solidFill>
                   <a:srgbClr val="555555"/>
                 </a:solidFill>
                 <a:latin typeface="Segoe UI"/>
               </a:rPr>
-              <a:t>10 / 12</a:t>
-            </a:r>
+              <a:t>8</a:t>
+            </a:fld>
+            <a:endParaRPr sz="1000" b="0">
+              <a:solidFill>
+                <a:srgbClr val="555555"/>
+              </a:solidFill>
+              <a:latin typeface="Segoe UI"/>
+            </a:endParaRPr>
           </a:p>
         </p:txBody>
       </p:sp>
@@ -12209,15 +12107,21 @@
           <a:lstStyle/>
           <a:p>
             <a:pPr algn="r"/>
-            <a:r>
+            <a:fld id="{11111111-1111-1111-1111-111111111111}" type="slidenum">
               <a:rPr sz="1000" b="0">
                 <a:solidFill>
                   <a:srgbClr val="555555"/>
                 </a:solidFill>
                 <a:latin typeface="Segoe UI"/>
               </a:rPr>
-              <a:t>11 / 12</a:t>
-            </a:r>
+              <a:t>9</a:t>
+            </a:fld>
+            <a:endParaRPr sz="1000" b="0">
+              <a:solidFill>
+                <a:srgbClr val="555555"/>
+              </a:solidFill>
+              <a:latin typeface="Segoe UI"/>
+            </a:endParaRPr>
           </a:p>
         </p:txBody>
       </p:sp>

</xml_diff>